<commit_message>
Pitch deck: partner tiles polish (-5% size, no captions)
- Cambodia + Singapore partner tiles shrunk 5% (slotH 0.95→0.90,
  maxH 0.65→0.62)
- Removed the gray caption below each tile — brand names live inside
  the logos themselves, the extra text was redundant

Co-Authored-By: Claude Opus 4.7 <noreply@anthropic.com>
</commit_message>
<xml_diff>
--- a/yaikh-com/deck/Yai-Pitch-Deck.pptx
+++ b/yaikh-com/deck/Yai-Pitch-Deck.pptx
@@ -13330,46 +13330,7 @@
       </p:pic>
       <p:sp>
         <p:nvSpPr>
-          <p:cNvPr id="17" name="Text 12"/>
-          <p:cNvSpPr/>
-          <p:nvPr/>
-        </p:nvSpPr>
-        <p:spPr>
-          <a:xfrm>
-            <a:off x="4572000" y="3172968"/>
-            <a:ext cx="3200400" cy="256032"/>
-          </a:xfrm>
-          <a:prstGeom prst="rect">
-            <a:avLst/>
-          </a:prstGeom>
-          <a:noFill/>
-          <a:ln/>
-        </p:spPr>
-        <p:txBody>
-          <a:bodyPr wrap="square" lIns="0" tIns="0" rIns="0" bIns="0" rtlCol="0" anchor="ctr"/>
-          <a:lstStyle/>
-          <a:p>
-            <a:pPr algn="ctr" indent="0" marL="0">
-              <a:buNone/>
-            </a:pPr>
-            <a:r>
-              <a:rPr lang="en-US" sz="1000" b="1" dirty="0">
-                <a:solidFill>
-                  <a:srgbClr val="64748B"/>
-                </a:solidFill>
-                <a:latin typeface="Arial" pitchFamily="34" charset="0"/>
-                <a:ea typeface="Arial" pitchFamily="34" charset="-122"/>
-                <a:cs typeface="Arial" pitchFamily="34" charset="-120"/>
-              </a:rPr>
-              <a:t>TAFTAC</a:t>
-            </a:r>
-            <a:endParaRPr lang="en-US" sz="1000" dirty="0"/>
-          </a:p>
-        </p:txBody>
-      </p:sp>
-      <p:sp>
-        <p:nvSpPr>
-          <p:cNvPr id="18" name="Shape 13"/>
+          <p:cNvPr id="17" name="Shape 12"/>
           <p:cNvSpPr/>
           <p:nvPr/>
         </p:nvSpPr>
@@ -13396,7 +13357,7 @@
       </p:sp>
       <p:pic>
         <p:nvPicPr>
-          <p:cNvPr id="19" name="Image 3" descr="preencoded.png">    </p:cNvPr>
+          <p:cNvPr id="18" name="Image 3" descr="preencoded.png">    </p:cNvPr>
           <p:cNvPicPr>
             <a:picLocks noChangeAspect="1"/>
           </p:cNvPicPr>
@@ -13420,46 +13381,7 @@
       </p:pic>
       <p:sp>
         <p:nvSpPr>
-          <p:cNvPr id="20" name="Text 14"/>
-          <p:cNvSpPr/>
-          <p:nvPr/>
-        </p:nvSpPr>
-        <p:spPr>
-          <a:xfrm>
-            <a:off x="4572000" y="3995928"/>
-            <a:ext cx="3200400" cy="256032"/>
-          </a:xfrm>
-          <a:prstGeom prst="rect">
-            <a:avLst/>
-          </a:prstGeom>
-          <a:noFill/>
-          <a:ln/>
-        </p:spPr>
-        <p:txBody>
-          <a:bodyPr wrap="square" lIns="0" tIns="0" rIns="0" bIns="0" rtlCol="0" anchor="ctr"/>
-          <a:lstStyle/>
-          <a:p>
-            <a:pPr algn="ctr" indent="0" marL="0">
-              <a:buNone/>
-            </a:pPr>
-            <a:r>
-              <a:rPr lang="en-US" sz="1000" b="1" dirty="0">
-                <a:solidFill>
-                  <a:srgbClr val="64748B"/>
-                </a:solidFill>
-                <a:latin typeface="Arial" pitchFamily="34" charset="0"/>
-                <a:ea typeface="Arial" pitchFamily="34" charset="-122"/>
-                <a:cs typeface="Arial" pitchFamily="34" charset="-120"/>
-              </a:rPr>
-              <a:t>SBC Cambodia</a:t>
-            </a:r>
-            <a:endParaRPr lang="en-US" sz="1000" dirty="0"/>
-          </a:p>
-        </p:txBody>
-      </p:sp>
-      <p:sp>
-        <p:nvSpPr>
-          <p:cNvPr id="21" name="Shape 15"/>
+          <p:cNvPr id="19" name="Shape 13"/>
           <p:cNvSpPr/>
           <p:nvPr/>
         </p:nvSpPr>
@@ -13486,7 +13408,7 @@
       </p:sp>
       <p:pic>
         <p:nvPicPr>
-          <p:cNvPr id="22" name="Image 4" descr="preencoded.png">    </p:cNvPr>
+          <p:cNvPr id="20" name="Image 4" descr="preencoded.png">    </p:cNvPr>
           <p:cNvPicPr>
             <a:picLocks noChangeAspect="1"/>
           </p:cNvPicPr>
@@ -13510,46 +13432,7 @@
       </p:pic>
       <p:sp>
         <p:nvSpPr>
-          <p:cNvPr id="23" name="Text 16"/>
-          <p:cNvSpPr/>
-          <p:nvPr/>
-        </p:nvSpPr>
-        <p:spPr>
-          <a:xfrm>
-            <a:off x="4572000" y="4818888"/>
-            <a:ext cx="3200400" cy="256032"/>
-          </a:xfrm>
-          <a:prstGeom prst="rect">
-            <a:avLst/>
-          </a:prstGeom>
-          <a:noFill/>
-          <a:ln/>
-        </p:spPr>
-        <p:txBody>
-          <a:bodyPr wrap="square" lIns="0" tIns="0" rIns="0" bIns="0" rtlCol="0" anchor="ctr"/>
-          <a:lstStyle/>
-          <a:p>
-            <a:pPr algn="ctr" indent="0" marL="0">
-              <a:buNone/>
-            </a:pPr>
-            <a:r>
-              <a:rPr lang="en-US" sz="1000" b="1" dirty="0">
-                <a:solidFill>
-                  <a:srgbClr val="64748B"/>
-                </a:solidFill>
-                <a:latin typeface="Arial" pitchFamily="34" charset="0"/>
-                <a:ea typeface="Arial" pitchFamily="34" charset="-122"/>
-                <a:cs typeface="Arial" pitchFamily="34" charset="-120"/>
-              </a:rPr>
-              <a:t>CambodiaTrade</a:t>
-            </a:r>
-            <a:endParaRPr lang="en-US" sz="1000" dirty="0"/>
-          </a:p>
-        </p:txBody>
-      </p:sp>
-      <p:sp>
-        <p:nvSpPr>
-          <p:cNvPr id="24" name="Text 17"/>
+          <p:cNvPr id="21" name="Text 14"/>
           <p:cNvSpPr/>
           <p:nvPr/>
         </p:nvSpPr>
@@ -13588,7 +13471,7 @@
       </p:sp>
       <p:sp>
         <p:nvSpPr>
-          <p:cNvPr id="25" name="Shape 18"/>
+          <p:cNvPr id="22" name="Shape 15"/>
           <p:cNvSpPr/>
           <p:nvPr/>
         </p:nvSpPr>
@@ -13615,7 +13498,7 @@
       </p:sp>
       <p:pic>
         <p:nvPicPr>
-          <p:cNvPr id="26" name="Image 5" descr="preencoded.png">    </p:cNvPr>
+          <p:cNvPr id="23" name="Image 5" descr="preencoded.png">    </p:cNvPr>
           <p:cNvPicPr>
             <a:picLocks noChangeAspect="1"/>
           </p:cNvPicPr>
@@ -13639,7 +13522,7 @@
       </p:pic>
       <p:sp>
         <p:nvSpPr>
-          <p:cNvPr id="27" name="Text 19"/>
+          <p:cNvPr id="24" name="Text 16"/>
           <p:cNvSpPr/>
           <p:nvPr/>
         </p:nvSpPr>
@@ -13678,7 +13561,7 @@
       </p:sp>
       <p:sp>
         <p:nvSpPr>
-          <p:cNvPr id="28" name="Text 20"/>
+          <p:cNvPr id="25" name="Text 17"/>
           <p:cNvSpPr/>
           <p:nvPr/>
         </p:nvSpPr>
@@ -13717,7 +13600,7 @@
       </p:sp>
       <p:sp>
         <p:nvSpPr>
-          <p:cNvPr id="29" name="Shape 21"/>
+          <p:cNvPr id="26" name="Shape 18"/>
           <p:cNvSpPr/>
           <p:nvPr/>
         </p:nvSpPr>
@@ -13744,7 +13627,7 @@
       </p:sp>
       <p:pic>
         <p:nvPicPr>
-          <p:cNvPr id="30" name="Image 6" descr="preencoded.png">    </p:cNvPr>
+          <p:cNvPr id="27" name="Image 6" descr="preencoded.png">    </p:cNvPr>
           <p:cNvPicPr>
             <a:picLocks noChangeAspect="1"/>
           </p:cNvPicPr>
@@ -13768,46 +13651,7 @@
       </p:pic>
       <p:sp>
         <p:nvSpPr>
-          <p:cNvPr id="31" name="Text 22"/>
-          <p:cNvSpPr/>
-          <p:nvPr/>
-        </p:nvSpPr>
-        <p:spPr>
-          <a:xfrm>
-            <a:off x="8366760" y="3172968"/>
-            <a:ext cx="3200400" cy="256032"/>
-          </a:xfrm>
-          <a:prstGeom prst="rect">
-            <a:avLst/>
-          </a:prstGeom>
-          <a:noFill/>
-          <a:ln/>
-        </p:spPr>
-        <p:txBody>
-          <a:bodyPr wrap="square" lIns="0" tIns="0" rIns="0" bIns="0" rtlCol="0" anchor="ctr"/>
-          <a:lstStyle/>
-          <a:p>
-            <a:pPr algn="ctr" indent="0" marL="0">
-              <a:buNone/>
-            </a:pPr>
-            <a:r>
-              <a:rPr lang="en-US" sz="1000" b="1" dirty="0">
-                <a:solidFill>
-                  <a:srgbClr val="64748B"/>
-                </a:solidFill>
-                <a:latin typeface="Arial" pitchFamily="34" charset="0"/>
-                <a:ea typeface="Arial" pitchFamily="34" charset="-122"/>
-                <a:cs typeface="Arial" pitchFamily="34" charset="-120"/>
-              </a:rPr>
-              <a:t>Singapore Fashion Council</a:t>
-            </a:r>
-            <a:endParaRPr lang="en-US" sz="1000" dirty="0"/>
-          </a:p>
-        </p:txBody>
-      </p:sp>
-      <p:sp>
-        <p:nvSpPr>
-          <p:cNvPr id="32" name="Shape 23"/>
+          <p:cNvPr id="28" name="Shape 19"/>
           <p:cNvSpPr/>
           <p:nvPr/>
         </p:nvSpPr>
@@ -13834,7 +13678,7 @@
       </p:sp>
       <p:pic>
         <p:nvPicPr>
-          <p:cNvPr id="33" name="Image 7" descr="preencoded.png">    </p:cNvPr>
+          <p:cNvPr id="29" name="Image 7" descr="preencoded.png">    </p:cNvPr>
           <p:cNvPicPr>
             <a:picLocks noChangeAspect="1"/>
           </p:cNvPicPr>
@@ -13858,46 +13702,7 @@
       </p:pic>
       <p:sp>
         <p:nvSpPr>
-          <p:cNvPr id="34" name="Text 24"/>
-          <p:cNvSpPr/>
-          <p:nvPr/>
-        </p:nvSpPr>
-        <p:spPr>
-          <a:xfrm>
-            <a:off x="8366760" y="3995928"/>
-            <a:ext cx="3200400" cy="256032"/>
-          </a:xfrm>
-          <a:prstGeom prst="rect">
-            <a:avLst/>
-          </a:prstGeom>
-          <a:noFill/>
-          <a:ln/>
-        </p:spPr>
-        <p:txBody>
-          <a:bodyPr wrap="square" lIns="0" tIns="0" rIns="0" bIns="0" rtlCol="0" anchor="ctr"/>
-          <a:lstStyle/>
-          <a:p>
-            <a:pPr algn="ctr" indent="0" marL="0">
-              <a:buNone/>
-            </a:pPr>
-            <a:r>
-              <a:rPr lang="en-US" sz="1000" b="1" dirty="0">
-                <a:solidFill>
-                  <a:srgbClr val="64748B"/>
-                </a:solidFill>
-                <a:latin typeface="Arial" pitchFamily="34" charset="0"/>
-                <a:ea typeface="Arial" pitchFamily="34" charset="-122"/>
-                <a:cs typeface="Arial" pitchFamily="34" charset="-120"/>
-              </a:rPr>
-              <a:t>TaF.tc</a:t>
-            </a:r>
-            <a:endParaRPr lang="en-US" sz="1000" dirty="0"/>
-          </a:p>
-        </p:txBody>
-      </p:sp>
-      <p:sp>
-        <p:nvSpPr>
-          <p:cNvPr id="35" name="Shape 25"/>
+          <p:cNvPr id="30" name="Shape 20"/>
           <p:cNvSpPr/>
           <p:nvPr/>
         </p:nvSpPr>
@@ -13924,7 +13729,7 @@
       </p:sp>
       <p:pic>
         <p:nvPicPr>
-          <p:cNvPr id="36" name="Image 8" descr="preencoded.png">    </p:cNvPr>
+          <p:cNvPr id="31" name="Image 8" descr="preencoded.png">    </p:cNvPr>
           <p:cNvPicPr>
             <a:picLocks noChangeAspect="1"/>
           </p:cNvPicPr>
@@ -13948,46 +13753,7 @@
       </p:pic>
       <p:sp>
         <p:nvSpPr>
-          <p:cNvPr id="37" name="Text 26"/>
-          <p:cNvSpPr/>
-          <p:nvPr/>
-        </p:nvSpPr>
-        <p:spPr>
-          <a:xfrm>
-            <a:off x="8366760" y="4818888"/>
-            <a:ext cx="3200400" cy="256032"/>
-          </a:xfrm>
-          <a:prstGeom prst="rect">
-            <a:avLst/>
-          </a:prstGeom>
-          <a:noFill/>
-          <a:ln/>
-        </p:spPr>
-        <p:txBody>
-          <a:bodyPr wrap="square" lIns="0" tIns="0" rIns="0" bIns="0" rtlCol="0" anchor="ctr"/>
-          <a:lstStyle/>
-          <a:p>
-            <a:pPr algn="ctr" indent="0" marL="0">
-              <a:buNone/>
-            </a:pPr>
-            <a:r>
-              <a:rPr lang="en-US" sz="1000" b="1" dirty="0">
-                <a:solidFill>
-                  <a:srgbClr val="64748B"/>
-                </a:solidFill>
-                <a:latin typeface="Arial" pitchFamily="34" charset="0"/>
-                <a:ea typeface="Arial" pitchFamily="34" charset="-122"/>
-                <a:cs typeface="Arial" pitchFamily="34" charset="-120"/>
-              </a:rPr>
-              <a:t>Enterprise Singapore</a:t>
-            </a:r>
-            <a:endParaRPr lang="en-US" sz="1000" dirty="0"/>
-          </a:p>
-        </p:txBody>
-      </p:sp>
-      <p:sp>
-        <p:nvSpPr>
-          <p:cNvPr id="38" name="Text 27"/>
+          <p:cNvPr id="32" name="Text 21"/>
           <p:cNvSpPr/>
           <p:nvPr/>
         </p:nvSpPr>
@@ -14026,7 +13792,7 @@
       </p:sp>
       <p:sp>
         <p:nvSpPr>
-          <p:cNvPr id="39" name="Text 28"/>
+          <p:cNvPr id="33" name="Text 22"/>
           <p:cNvSpPr/>
           <p:nvPr/>
         </p:nvSpPr>

</xml_diff>